<commit_message>
Presentation: reframe the agenda and drop chapter numbering
Title kicker becomes "Cloudlet's Serverless", the agenda slide is now
"What we'll talk about" with the topics listed, and the deck is split into
logical sections without chapter numbers: section dividers carry only the
section name and the kicker on each slide names the section.

Co-Authored-By: Claude Fable 5.1 <noreply@anthropic.com>
Claude-Session: https://claude.ai/code/session_01VYh5cmYiRsfhgqCGhixHm5
</commit_message>
<xml_diff>
--- a/docs/presentation/serverless-platform.pptx
+++ b/docs/presentation/serverless-platform.pptx
@@ -2866,7 +2866,7 @@
                 <a:ea typeface="Courier New" pitchFamily="34" charset="-122"/>
                 <a:cs typeface="Courier New" pitchFamily="34" charset="-120"/>
               </a:rPr>
-              <a:t>SERVERLESS ON CLOUDLET</a:t>
+              <a:t>CLOUDLET'S SERVERLESS</a:t>
             </a:r>
             <a:endParaRPr lang="en-US" sz="1200" dirty="0"/>
           </a:p>
@@ -3147,7 +3147,7 @@
                 <a:ea typeface="Courier New" pitchFamily="34" charset="-122"/>
                 <a:cs typeface="Courier New" pitchFamily="34" charset="-120"/>
               </a:rPr>
-              <a:t>CHAPTER 02 · THE API</a:t>
+              <a:t>THE API</a:t>
             </a:r>
             <a:endParaRPr lang="en-US" sz="1100" dirty="0"/>
           </a:p>
@@ -4872,7 +4872,7 @@
                 <a:ea typeface="Courier New" pitchFamily="34" charset="-122"/>
                 <a:cs typeface="Courier New" pitchFamily="34" charset="-120"/>
               </a:rPr>
-              <a:t>CHAPTER 02 · THE API</a:t>
+              <a:t>THE API</a:t>
             </a:r>
             <a:endParaRPr lang="en-US" sz="1100" dirty="0"/>
           </a:p>
@@ -6337,7 +6337,7 @@
                 <a:ea typeface="Courier New" pitchFamily="34" charset="-122"/>
                 <a:cs typeface="Courier New" pitchFamily="34" charset="-120"/>
               </a:rPr>
-              <a:t>CHAPTER 02 · THE API</a:t>
+              <a:t>THE API</a:t>
             </a:r>
             <a:endParaRPr lang="en-US" sz="1100" dirty="0"/>
           </a:p>
@@ -7743,7 +7743,7 @@
                 <a:ea typeface="Courier New" pitchFamily="34" charset="-122"/>
                 <a:cs typeface="Courier New" pitchFamily="34" charset="-120"/>
               </a:rPr>
-              <a:t>CHAPTER 02 · THE API</a:t>
+              <a:t>THE API</a:t>
             </a:r>
             <a:endParaRPr lang="en-US" sz="1100" dirty="0"/>
           </a:p>
@@ -9337,8 +9337,8 @@
         </p:nvSpPr>
         <p:spPr>
           <a:xfrm>
-            <a:off x="640080" y="914400"/>
-            <a:ext cx="5486400" cy="2377440"/>
+            <a:off x="640080" y="2194560"/>
+            <a:ext cx="10515600" cy="1463040"/>
           </a:xfrm>
           <a:prstGeom prst="rect">
             <a:avLst/>
@@ -9354,7 +9354,7 @@
               <a:buNone/>
             </a:pPr>
             <a:r>
-              <a:rPr lang="en-US" sz="15000" b="1" dirty="0">
+              <a:rPr lang="en-US" sz="6400" b="1" dirty="0">
                 <a:solidFill>
                   <a:srgbClr val="FFFFFF"/>
                 </a:solidFill>
@@ -9362,9 +9362,9 @@
                 <a:ea typeface="Century Schoolbook" pitchFamily="34" charset="-122"/>
                 <a:cs typeface="Century Schoolbook" pitchFamily="34" charset="-120"/>
               </a:rPr>
-              <a:t>03</a:t>
-            </a:r>
-            <a:endParaRPr lang="en-US" sz="15000" dirty="0"/>
+              <a:t>Functions &amp; builds</a:t>
+            </a:r>
+            <a:endParaRPr lang="en-US" sz="6400" dirty="0"/>
           </a:p>
         </p:txBody>
       </p:sp>
@@ -9376,8 +9376,8 @@
         </p:nvSpPr>
         <p:spPr>
           <a:xfrm>
-            <a:off x="640080" y="3383280"/>
-            <a:ext cx="10058400" cy="914400"/>
+            <a:off x="640080" y="3749040"/>
+            <a:ext cx="9144000" cy="548640"/>
           </a:xfrm>
           <a:prstGeom prst="rect">
             <a:avLst/>
@@ -9393,7 +9393,7 @@
               <a:buNone/>
             </a:pPr>
             <a:r>
-              <a:rPr lang="en-US" sz="4800" b="1" dirty="0">
+              <a:rPr lang="en-US" sz="2200" i="1" dirty="0">
                 <a:solidFill>
                   <a:srgbClr val="FFFFFF"/>
                 </a:solidFill>
@@ -9401,54 +9401,15 @@
                 <a:ea typeface="Century Schoolbook" pitchFamily="34" charset="-122"/>
                 <a:cs typeface="Century Schoolbook" pitchFamily="34" charset="-120"/>
               </a:rPr>
-              <a:t>Functions &amp; builds</a:t>
-            </a:r>
-            <a:endParaRPr lang="en-US" sz="4800" dirty="0"/>
+              <a:t>'Here is my repo' hides a build.</a:t>
+            </a:r>
+            <a:endParaRPr lang="en-US" sz="2200" dirty="0"/>
           </a:p>
         </p:txBody>
       </p:sp>
       <p:sp>
         <p:nvSpPr>
           <p:cNvPr id="4" name="Text 2"/>
-          <p:cNvSpPr txBox="1"/>
-          <p:nvPr/>
-        </p:nvSpPr>
-        <p:spPr>
-          <a:xfrm>
-            <a:off x="640080" y="4343400"/>
-            <a:ext cx="9144000" cy="548640"/>
-          </a:xfrm>
-          <a:prstGeom prst="rect">
-            <a:avLst/>
-          </a:prstGeom>
-          <a:noFill/>
-          <a:ln/>
-        </p:spPr>
-        <p:txBody>
-          <a:bodyPr wrap="square" lIns="0" tIns="0" rIns="0" bIns="0" rtlCol="0" anchor="ctr"/>
-          <a:lstStyle/>
-          <a:p>
-            <a:pPr indent="0" marL="0">
-              <a:buNone/>
-            </a:pPr>
-            <a:r>
-              <a:rPr lang="en-US" sz="2200" i="1" dirty="0">
-                <a:solidFill>
-                  <a:srgbClr val="FFFFFF"/>
-                </a:solidFill>
-                <a:latin typeface="Century Schoolbook" pitchFamily="34" charset="0"/>
-                <a:ea typeface="Century Schoolbook" pitchFamily="34" charset="-122"/>
-                <a:cs typeface="Century Schoolbook" pitchFamily="34" charset="-120"/>
-              </a:rPr>
-              <a:t>'Here is my repo' hides a build.</a:t>
-            </a:r>
-            <a:endParaRPr lang="en-US" sz="2200" dirty="0"/>
-          </a:p>
-        </p:txBody>
-      </p:sp>
-      <p:sp>
-        <p:nvSpPr>
-          <p:cNvPr id="5" name="Text 3"/>
           <p:cNvSpPr txBox="1"/>
           <p:nvPr/>
         </p:nvSpPr>
@@ -9553,7 +9514,7 @@
                 <a:ea typeface="Courier New" pitchFamily="34" charset="-122"/>
                 <a:cs typeface="Courier New" pitchFamily="34" charset="-120"/>
               </a:rPr>
-              <a:t>CHAPTER 03 · FUNCTIONS &amp; BUILDS</a:t>
+              <a:t>FUNCTIONS &amp; BUILDS</a:t>
             </a:r>
             <a:endParaRPr lang="en-US" sz="1100" dirty="0"/>
           </a:p>
@@ -11101,7 +11062,7 @@
                 <a:ea typeface="Courier New" pitchFamily="34" charset="-122"/>
                 <a:cs typeface="Courier New" pitchFamily="34" charset="-120"/>
               </a:rPr>
-              <a:t>CHAPTER 03 · FUNCTIONS &amp; BUILDS</a:t>
+              <a:t>FUNCTIONS &amp; BUILDS</a:t>
             </a:r>
             <a:endParaRPr lang="en-US" sz="1100" dirty="0"/>
           </a:p>
@@ -12803,7 +12764,7 @@
                 <a:ea typeface="Courier New" pitchFamily="34" charset="-122"/>
                 <a:cs typeface="Courier New" pitchFamily="34" charset="-120"/>
               </a:rPr>
-              <a:t>CHAPTER 03 · FUNCTIONS &amp; BUILDS</a:t>
+              <a:t>FUNCTIONS &amp; BUILDS</a:t>
             </a:r>
             <a:endParaRPr lang="en-US" sz="1100" dirty="0"/>
           </a:p>
@@ -14765,7 +14726,7 @@
                 <a:ea typeface="Courier New" pitchFamily="34" charset="-122"/>
                 <a:cs typeface="Courier New" pitchFamily="34" charset="-120"/>
               </a:rPr>
-              <a:t>CHAPTER 03 · FUNCTIONS &amp; BUILDS</a:t>
+              <a:t>FUNCTIONS &amp; BUILDS</a:t>
             </a:r>
             <a:endParaRPr lang="en-US" sz="1100" dirty="0"/>
           </a:p>
@@ -16205,8 +16166,8 @@
         </p:nvSpPr>
         <p:spPr>
           <a:xfrm>
-            <a:off x="640080" y="914400"/>
-            <a:ext cx="5486400" cy="2377440"/>
+            <a:off x="640080" y="2194560"/>
+            <a:ext cx="10515600" cy="1463040"/>
           </a:xfrm>
           <a:prstGeom prst="rect">
             <a:avLst/>
@@ -16222,7 +16183,7 @@
               <a:buNone/>
             </a:pPr>
             <a:r>
-              <a:rPr lang="en-US" sz="15000" b="1" dirty="0">
+              <a:rPr lang="en-US" sz="6400" b="1" dirty="0">
                 <a:solidFill>
                   <a:srgbClr val="FFFFFF"/>
                 </a:solidFill>
@@ -16230,9 +16191,9 @@
                 <a:ea typeface="Century Schoolbook" pitchFamily="34" charset="-122"/>
                 <a:cs typeface="Century Schoolbook" pitchFamily="34" charset="-120"/>
               </a:rPr>
-              <a:t>04</a:t>
-            </a:r>
-            <a:endParaRPr lang="en-US" sz="15000" dirty="0"/>
+              <a:t>Portal &amp; the future</a:t>
+            </a:r>
+            <a:endParaRPr lang="en-US" sz="6400" dirty="0"/>
           </a:p>
         </p:txBody>
       </p:sp>
@@ -16244,8 +16205,8 @@
         </p:nvSpPr>
         <p:spPr>
           <a:xfrm>
-            <a:off x="640080" y="3383280"/>
-            <a:ext cx="10058400" cy="914400"/>
+            <a:off x="640080" y="3749040"/>
+            <a:ext cx="9144000" cy="548640"/>
           </a:xfrm>
           <a:prstGeom prst="rect">
             <a:avLst/>
@@ -16261,7 +16222,7 @@
               <a:buNone/>
             </a:pPr>
             <a:r>
-              <a:rPr lang="en-US" sz="4800" b="1" dirty="0">
+              <a:rPr lang="en-US" sz="2200" i="1" dirty="0">
                 <a:solidFill>
                   <a:srgbClr val="FFFFFF"/>
                 </a:solidFill>
@@ -16269,54 +16230,15 @@
                 <a:ea typeface="Century Schoolbook" pitchFamily="34" charset="-122"/>
                 <a:cs typeface="Century Schoolbook" pitchFamily="34" charset="-120"/>
               </a:rPr>
-              <a:t>Portal &amp; the future</a:t>
-            </a:r>
-            <a:endParaRPr lang="en-US" sz="4800" dirty="0"/>
+              <a:t>A console, and a library for the next API.</a:t>
+            </a:r>
+            <a:endParaRPr lang="en-US" sz="2200" dirty="0"/>
           </a:p>
         </p:txBody>
       </p:sp>
       <p:sp>
         <p:nvSpPr>
           <p:cNvPr id="4" name="Text 2"/>
-          <p:cNvSpPr txBox="1"/>
-          <p:nvPr/>
-        </p:nvSpPr>
-        <p:spPr>
-          <a:xfrm>
-            <a:off x="640080" y="4343400"/>
-            <a:ext cx="9144000" cy="548640"/>
-          </a:xfrm>
-          <a:prstGeom prst="rect">
-            <a:avLst/>
-          </a:prstGeom>
-          <a:noFill/>
-          <a:ln/>
-        </p:spPr>
-        <p:txBody>
-          <a:bodyPr wrap="square" lIns="0" tIns="0" rIns="0" bIns="0" rtlCol="0" anchor="ctr"/>
-          <a:lstStyle/>
-          <a:p>
-            <a:pPr indent="0" marL="0">
-              <a:buNone/>
-            </a:pPr>
-            <a:r>
-              <a:rPr lang="en-US" sz="2200" i="1" dirty="0">
-                <a:solidFill>
-                  <a:srgbClr val="FFFFFF"/>
-                </a:solidFill>
-                <a:latin typeface="Century Schoolbook" pitchFamily="34" charset="0"/>
-                <a:ea typeface="Century Schoolbook" pitchFamily="34" charset="-122"/>
-                <a:cs typeface="Century Schoolbook" pitchFamily="34" charset="-120"/>
-              </a:rPr>
-              <a:t>A console, and a library for the next API.</a:t>
-            </a:r>
-            <a:endParaRPr lang="en-US" sz="2200" dirty="0"/>
-          </a:p>
-        </p:txBody>
-      </p:sp>
-      <p:sp>
-        <p:nvSpPr>
-          <p:cNvPr id="5" name="Text 3"/>
           <p:cNvSpPr txBox="1"/>
           <p:nvPr/>
         </p:nvSpPr>
@@ -16421,7 +16343,7 @@
                 <a:ea typeface="Courier New" pitchFamily="34" charset="-122"/>
                 <a:cs typeface="Courier New" pitchFamily="34" charset="-120"/>
               </a:rPr>
-              <a:t>AGENDA</a:t>
+              <a:t>TODAY</a:t>
             </a:r>
             <a:endParaRPr lang="en-US" sz="1100" dirty="0"/>
           </a:p>
@@ -16460,7 +16382,7 @@
                 <a:ea typeface="Century Schoolbook" pitchFamily="34" charset="-122"/>
                 <a:cs typeface="Century Schoolbook" pitchFamily="34" charset="-120"/>
               </a:rPr>
-              <a:t>Four chapters</a:t>
+              <a:t>What we'll talk about</a:t>
             </a:r>
             <a:endParaRPr lang="en-US" sz="3800" dirty="0"/>
           </a:p>
@@ -16524,7 +16446,7 @@
                 <a:ea typeface="Calibri" pitchFamily="34" charset="-122"/>
                 <a:cs typeface="Calibri" pitchFamily="34" charset="-120"/>
               </a:rPr>
-              <a:t>01  Foundations: serverless, Knative, the Operator</a:t>
+              <a:t>Serverless, Knative and the Operator</a:t>
             </a:r>
             <a:endParaRPr lang="en-US" sz="1900" dirty="0"/>
           </a:p>
@@ -16588,7 +16510,7 @@
                 <a:ea typeface="Calibri" pitchFamily="34" charset="-122"/>
                 <a:cs typeface="Calibri" pitchFamily="34" charset="-120"/>
               </a:rPr>
-              <a:t>02  The API: contract, mTLS, two regions</a:t>
+              <a:t>The API: contract, mTLS, two regions</a:t>
             </a:r>
             <a:endParaRPr lang="en-US" sz="1900" dirty="0"/>
           </a:p>
@@ -16652,7 +16574,7 @@
                 <a:ea typeface="Calibri" pitchFamily="34" charset="-122"/>
                 <a:cs typeface="Calibri" pitchFamily="34" charset="-120"/>
               </a:rPr>
-              <a:t>03  Functions: buildpacks, kpack, build controller</a:t>
+              <a:t>Functions: buildpacks, kpack, build controller</a:t>
             </a:r>
             <a:endParaRPr lang="en-US" sz="1900" dirty="0"/>
           </a:p>
@@ -16716,7 +16638,7 @@
                 <a:ea typeface="Calibri" pitchFamily="34" charset="-122"/>
                 <a:cs typeface="Calibri" pitchFamily="34" charset="-120"/>
               </a:rPr>
-              <a:t>04  Portal and cloudlet-apis: what comes next</a:t>
+              <a:t>The portal and cloudlet-apis</a:t>
             </a:r>
             <a:endParaRPr lang="en-US" sz="1900" dirty="0"/>
           </a:p>
@@ -16724,7 +16646,71 @@
       </p:sp>
       <p:sp>
         <p:nvSpPr>
-          <p:cNvPr id="13" name="Text 10"/>
+          <p:cNvPr id="13" name="step:5"/>
+          <p:cNvSpPr/>
+          <p:nvPr/>
+        </p:nvSpPr>
+        <p:spPr>
+          <a:xfrm>
+            <a:off x="640080" y="5001768"/>
+            <a:ext cx="118872" cy="118872"/>
+          </a:xfrm>
+          <a:prstGeom prst="rect">
+            <a:avLst/>
+          </a:prstGeom>
+          <a:solidFill>
+            <a:srgbClr val="E4572E"/>
+          </a:solidFill>
+          <a:ln w="12700">
+            <a:solidFill>
+              <a:srgbClr val="E4572E"/>
+            </a:solidFill>
+            <a:prstDash val="solid"/>
+          </a:ln>
+        </p:spPr>
+      </p:sp>
+      <p:sp>
+        <p:nvSpPr>
+          <p:cNvPr id="14" name="step:5"/>
+          <p:cNvSpPr txBox="1"/>
+          <p:nvPr/>
+        </p:nvSpPr>
+        <p:spPr>
+          <a:xfrm>
+            <a:off x="960120" y="4736592"/>
+            <a:ext cx="4983480" cy="658368"/>
+          </a:xfrm>
+          <a:prstGeom prst="rect">
+            <a:avLst/>
+          </a:prstGeom>
+          <a:noFill/>
+          <a:ln/>
+        </p:spPr>
+        <p:txBody>
+          <a:bodyPr wrap="square" lIns="0" tIns="0" rIns="0" bIns="0" rtlCol="0" anchor="ctr"/>
+          <a:lstStyle/>
+          <a:p>
+            <a:pPr indent="0" marL="0">
+              <a:buNone/>
+            </a:pPr>
+            <a:r>
+              <a:rPr lang="en-US" sz="1900" dirty="0">
+                <a:solidFill>
+                  <a:srgbClr val="1B1F2A"/>
+                </a:solidFill>
+                <a:latin typeface="Calibri" pitchFamily="34" charset="0"/>
+                <a:ea typeface="Calibri" pitchFamily="34" charset="-122"/>
+                <a:cs typeface="Calibri" pitchFamily="34" charset="-120"/>
+              </a:rPr>
+              <a:t>Where we go next</a:t>
+            </a:r>
+            <a:endParaRPr lang="en-US" sz="1900" dirty="0"/>
+          </a:p>
+        </p:txBody>
+      </p:sp>
+      <p:sp>
+        <p:nvSpPr>
+          <p:cNvPr id="15" name="Text 12"/>
           <p:cNvSpPr txBox="1"/>
           <p:nvPr/>
         </p:nvSpPr>
@@ -16755,7 +16741,7 @@
                 <a:ea typeface="Century Schoolbook" pitchFamily="34" charset="-122"/>
                 <a:cs typeface="Century Schoolbook" pitchFamily="34" charset="-120"/>
               </a:rPr>
-              <a:t>01 → 04</a:t>
+              <a:t>23</a:t>
             </a:r>
             <a:endParaRPr lang="en-US" sz="5400" dirty="0"/>
           </a:p>
@@ -16763,7 +16749,7 @@
       </p:sp>
       <p:sp>
         <p:nvSpPr>
-          <p:cNvPr id="14" name="Text 11"/>
+          <p:cNvPr id="16" name="Text 13"/>
           <p:cNvSpPr txBox="1"/>
           <p:nvPr/>
         </p:nvSpPr>
@@ -16794,7 +16780,7 @@
                 <a:ea typeface="Courier New" pitchFamily="34" charset="-122"/>
                 <a:cs typeface="Courier New" pitchFamily="34" charset="-120"/>
               </a:rPr>
-              <a:t>fourteen questions, one platform</a:t>
+              <a:t>slides · four topics · one platform</a:t>
             </a:r>
             <a:endParaRPr lang="en-US" sz="1100" dirty="0"/>
           </a:p>
@@ -16802,7 +16788,7 @@
       </p:sp>
       <p:sp>
         <p:nvSpPr>
-          <p:cNvPr id="15" name="Text 12"/>
+          <p:cNvPr id="17" name="Text 14"/>
           <p:cNvSpPr txBox="1"/>
           <p:nvPr/>
         </p:nvSpPr>
@@ -17195,6 +17181,94 @@
                                         <p:cTn id="32" dur="400"/>
                                         <p:tgtEl>
                                           <p:spTgt spid="12"/>
+                                        </p:tgtEl>
+                                      </p:cBhvr>
+                                    </p:animEffect>
+                                  </p:childTnLst>
+                                </p:cTn>
+                              </p:par>
+                            </p:childTnLst>
+                          </p:cTn>
+                        </p:par>
+                      </p:childTnLst>
+                    </p:cTn>
+                  </p:par>
+                  <p:par>
+                    <p:cTn id="41" fill="hold">
+                      <p:stCondLst>
+                        <p:cond delay="indefinite"/>
+                      </p:stCondLst>
+                      <p:childTnLst>
+                        <p:par>
+                          <p:cTn id="42" fill="hold">
+                            <p:stCondLst>
+                              <p:cond delay="0"/>
+                            </p:stCondLst>
+                            <p:childTnLst>
+                              <p:par>
+                                <p:cTn id="35" presetID="10" presetClass="entr" presetSubtype="0" fill="hold" grpId="0" nodeType="clickEffect">
+                                  <p:stCondLst>
+                                    <p:cond delay="0"/>
+                                  </p:stCondLst>
+                                  <p:childTnLst>
+                                    <p:set>
+                                      <p:cBhvr>
+                                        <p:cTn id="36" dur="1" fill="hold">
+                                          <p:stCondLst>
+                                            <p:cond delay="0"/>
+                                          </p:stCondLst>
+                                        </p:cTn>
+                                        <p:tgtEl>
+                                          <p:spTgt spid="13"/>
+                                        </p:tgtEl>
+                                        <p:attrNameLst>
+                                          <p:attrName>style.visibility</p:attrName>
+                                        </p:attrNameLst>
+                                      </p:cBhvr>
+                                      <p:to>
+                                        <p:strVal val="visible"/>
+                                      </p:to>
+                                    </p:set>
+                                    <p:animEffect transition="in" filter="fade">
+                                      <p:cBhvr>
+                                        <p:cTn id="37" dur="400"/>
+                                        <p:tgtEl>
+                                          <p:spTgt spid="13"/>
+                                        </p:tgtEl>
+                                      </p:cBhvr>
+                                    </p:animEffect>
+                                  </p:childTnLst>
+                                </p:cTn>
+                              </p:par>
+                              <p:par>
+                                <p:cTn id="38" presetID="10" presetClass="entr" presetSubtype="0" fill="hold" grpId="0" nodeType="withEffect">
+                                  <p:stCondLst>
+                                    <p:cond delay="0"/>
+                                  </p:stCondLst>
+                                  <p:childTnLst>
+                                    <p:set>
+                                      <p:cBhvr>
+                                        <p:cTn id="39" dur="1" fill="hold">
+                                          <p:stCondLst>
+                                            <p:cond delay="0"/>
+                                          </p:stCondLst>
+                                        </p:cTn>
+                                        <p:tgtEl>
+                                          <p:spTgt spid="14"/>
+                                        </p:tgtEl>
+                                        <p:attrNameLst>
+                                          <p:attrName>style.visibility</p:attrName>
+                                        </p:attrNameLst>
+                                      </p:cBhvr>
+                                      <p:to>
+                                        <p:strVal val="visible"/>
+                                      </p:to>
+                                    </p:set>
+                                    <p:animEffect transition="in" filter="fade">
+                                      <p:cBhvr>
+                                        <p:cTn id="40" dur="400"/>
+                                        <p:tgtEl>
+                                          <p:spTgt spid="14"/>
                                         </p:tgtEl>
                                       </p:cBhvr>
                                     </p:animEffect>
@@ -17237,6 +17311,8 @@
       <p:bldP spid="10" grpId="0"/>
       <p:bldP spid="11" grpId="0"/>
       <p:bldP spid="12" grpId="0"/>
+      <p:bldP spid="13" grpId="0"/>
+      <p:bldP spid="14" grpId="0"/>
     </p:bldLst>
   </p:timing>
 </p:sld>
@@ -17299,7 +17375,7 @@
                 <a:ea typeface="Courier New" pitchFamily="34" charset="-122"/>
                 <a:cs typeface="Courier New" pitchFamily="34" charset="-120"/>
               </a:rPr>
-              <a:t>CHAPTER 04 · PORTAL &amp; THE FUTURE</a:t>
+              <a:t>PORTAL &amp; THE FUTURE</a:t>
             </a:r>
             <a:endParaRPr lang="en-US" sz="1100" dirty="0"/>
           </a:p>
@@ -18942,7 +19018,7 @@
                 <a:ea typeface="Courier New" pitchFamily="34" charset="-122"/>
                 <a:cs typeface="Courier New" pitchFamily="34" charset="-120"/>
               </a:rPr>
-              <a:t>CHAPTER 04 · PORTAL &amp; THE FUTURE</a:t>
+              <a:t>PORTAL &amp; THE FUTURE</a:t>
             </a:r>
             <a:endParaRPr lang="en-US" sz="1100" dirty="0"/>
           </a:p>
@@ -20612,7 +20688,7 @@
                 <a:ea typeface="Courier New" pitchFamily="34" charset="-122"/>
                 <a:cs typeface="Courier New" pitchFamily="34" charset="-120"/>
               </a:rPr>
-              <a:t>CHAPTER 04 · PORTAL &amp; THE FUTURE</a:t>
+              <a:t>PORTAL &amp; THE FUTURE</a:t>
             </a:r>
             <a:endParaRPr lang="en-US" sz="1100" dirty="0"/>
           </a:p>
@@ -23782,7 +23858,7 @@
                 <a:ea typeface="Courier New" pitchFamily="34" charset="-122"/>
                 <a:cs typeface="Courier New" pitchFamily="34" charset="-120"/>
               </a:rPr>
-              <a:t>CHAPTER 01 · FOUNDATIONS</a:t>
+              <a:t>FOUNDATIONS</a:t>
             </a:r>
             <a:endParaRPr lang="en-US" sz="1100" dirty="0"/>
           </a:p>
@@ -24814,7 +24890,7 @@
                 <a:ea typeface="Courier New" pitchFamily="34" charset="-122"/>
                 <a:cs typeface="Courier New" pitchFamily="34" charset="-120"/>
               </a:rPr>
-              <a:t>CHAPTER 01 · FOUNDATIONS</a:t>
+              <a:t>FOUNDATIONS</a:t>
             </a:r>
             <a:endParaRPr lang="en-US" sz="1100" dirty="0"/>
           </a:p>
@@ -26433,7 +26509,7 @@
                 <a:ea typeface="Courier New" pitchFamily="34" charset="-122"/>
                 <a:cs typeface="Courier New" pitchFamily="34" charset="-120"/>
               </a:rPr>
-              <a:t>CHAPTER 01 · FOUNDATIONS</a:t>
+              <a:t>FOUNDATIONS</a:t>
             </a:r>
             <a:endParaRPr lang="en-US" sz="1100" dirty="0"/>
           </a:p>
@@ -27912,7 +27988,7 @@
                 <a:ea typeface="Courier New" pitchFamily="34" charset="-122"/>
                 <a:cs typeface="Courier New" pitchFamily="34" charset="-120"/>
               </a:rPr>
-              <a:t>CHAPTER 01 · FOUNDATIONS</a:t>
+              <a:t>FOUNDATIONS</a:t>
             </a:r>
             <a:endParaRPr lang="en-US" sz="1100" dirty="0"/>
           </a:p>
@@ -29313,8 +29389,8 @@
         </p:nvSpPr>
         <p:spPr>
           <a:xfrm>
-            <a:off x="640080" y="914400"/>
-            <a:ext cx="5486400" cy="2377440"/>
+            <a:off x="640080" y="2194560"/>
+            <a:ext cx="10515600" cy="1463040"/>
           </a:xfrm>
           <a:prstGeom prst="rect">
             <a:avLst/>
@@ -29330,7 +29406,7 @@
               <a:buNone/>
             </a:pPr>
             <a:r>
-              <a:rPr lang="en-US" sz="15000" b="1" dirty="0">
+              <a:rPr lang="en-US" sz="6400" b="1" dirty="0">
                 <a:solidFill>
                   <a:srgbClr val="FFFFFF"/>
                 </a:solidFill>
@@ -29338,9 +29414,9 @@
                 <a:ea typeface="Century Schoolbook" pitchFamily="34" charset="-122"/>
                 <a:cs typeface="Century Schoolbook" pitchFamily="34" charset="-120"/>
               </a:rPr>
-              <a:t>02</a:t>
-            </a:r>
-            <a:endParaRPr lang="en-US" sz="15000" dirty="0"/>
+              <a:t>The API</a:t>
+            </a:r>
+            <a:endParaRPr lang="en-US" sz="6400" dirty="0"/>
           </a:p>
         </p:txBody>
       </p:sp>
@@ -29352,8 +29428,8 @@
         </p:nvSpPr>
         <p:spPr>
           <a:xfrm>
-            <a:off x="640080" y="3383280"/>
-            <a:ext cx="10058400" cy="914400"/>
+            <a:off x="640080" y="3749040"/>
+            <a:ext cx="9144000" cy="548640"/>
           </a:xfrm>
           <a:prstGeom prst="rect">
             <a:avLst/>
@@ -29369,7 +29445,7 @@
               <a:buNone/>
             </a:pPr>
             <a:r>
-              <a:rPr lang="en-US" sz="4800" b="1" dirty="0">
+              <a:rPr lang="en-US" sz="2200" i="1" dirty="0">
                 <a:solidFill>
                   <a:srgbClr val="FFFFFF"/>
                 </a:solidFill>
@@ -29377,54 +29453,15 @@
                 <a:ea typeface="Century Schoolbook" pitchFamily="34" charset="-122"/>
                 <a:cs typeface="Century Schoolbook" pitchFamily="34" charset="-120"/>
               </a:rPr>
-              <a:t>The API</a:t>
-            </a:r>
-            <a:endParaRPr lang="en-US" sz="4800" dirty="0"/>
+              <a:t>One HTTP call, a workload on every cluster.</a:t>
+            </a:r>
+            <a:endParaRPr lang="en-US" sz="2200" dirty="0"/>
           </a:p>
         </p:txBody>
       </p:sp>
       <p:sp>
         <p:nvSpPr>
           <p:cNvPr id="4" name="Text 2"/>
-          <p:cNvSpPr txBox="1"/>
-          <p:nvPr/>
-        </p:nvSpPr>
-        <p:spPr>
-          <a:xfrm>
-            <a:off x="640080" y="4343400"/>
-            <a:ext cx="9144000" cy="548640"/>
-          </a:xfrm>
-          <a:prstGeom prst="rect">
-            <a:avLst/>
-          </a:prstGeom>
-          <a:noFill/>
-          <a:ln/>
-        </p:spPr>
-        <p:txBody>
-          <a:bodyPr wrap="square" lIns="0" tIns="0" rIns="0" bIns="0" rtlCol="0" anchor="ctr"/>
-          <a:lstStyle/>
-          <a:p>
-            <a:pPr indent="0" marL="0">
-              <a:buNone/>
-            </a:pPr>
-            <a:r>
-              <a:rPr lang="en-US" sz="2200" i="1" dirty="0">
-                <a:solidFill>
-                  <a:srgbClr val="FFFFFF"/>
-                </a:solidFill>
-                <a:latin typeface="Century Schoolbook" pitchFamily="34" charset="0"/>
-                <a:ea typeface="Century Schoolbook" pitchFamily="34" charset="-122"/>
-                <a:cs typeface="Century Schoolbook" pitchFamily="34" charset="-120"/>
-              </a:rPr>
-              <a:t>One HTTP call, a workload on every cluster.</a:t>
-            </a:r>
-            <a:endParaRPr lang="en-US" sz="2200" dirty="0"/>
-          </a:p>
-        </p:txBody>
-      </p:sp>
-      <p:sp>
-        <p:nvSpPr>
-          <p:cNvPr id="5" name="Text 3"/>
           <p:cNvSpPr txBox="1"/>
           <p:nvPr/>
         </p:nvSpPr>
@@ -29529,7 +29566,7 @@
                 <a:ea typeface="Courier New" pitchFamily="34" charset="-122"/>
                 <a:cs typeface="Courier New" pitchFamily="34" charset="-120"/>
               </a:rPr>
-              <a:t>CHAPTER 02 · THE API</a:t>
+              <a:t>THE API</a:t>
             </a:r>
             <a:endParaRPr lang="en-US" sz="1100" dirty="0"/>
           </a:p>
@@ -30795,7 +30832,7 @@
                 <a:ea typeface="Courier New" pitchFamily="34" charset="-122"/>
                 <a:cs typeface="Courier New" pitchFamily="34" charset="-120"/>
               </a:rPr>
-              <a:t>CHAPTER 02 · THE API</a:t>
+              <a:t>THE API</a:t>
             </a:r>
             <a:endParaRPr lang="en-US" sz="1100" dirty="0"/>
           </a:p>

</xml_diff>